<commit_message>
Allo Pneus septembre : ajout de la slide insights qualitatifs
Co-Authored-By: Claude Opus 5.5 <noreply@anthropic.com>
Claude-Session: https://claude.ai/code/session_01BmxtdWjbeRUyPx9e1qVLbT
</commit_message>
<xml_diff>
--- a/rapports/septembre/Allo_Pneus_sept2026.pptx
+++ b/rapports/septembre/Allo_Pneus_sept2026.pptx
@@ -6,6 +6,7 @@
   </p:sldMasterIdLst>
   <p:sldIdLst>
     <p:sldId id="256" r:id="rId7"/>
+    <p:sldId id="257" r:id="rId8"/>
   </p:sldIdLst>
   <p:sldSz cx="12192000" cy="6858000" type="screen4x3"/>
   <p:notesSz cx="6858000" cy="9144000"/>
@@ -6958,6 +6959,1040 @@
           <a:lstStyle/>
           <a:p>
             <a:pPr algn="ctr"/>
+          </a:p>
+        </p:txBody>
+      </p:sp>
+    </p:spTree>
+  </p:cSld>
+  <p:clrMapOvr>
+    <a:masterClrMapping/>
+  </p:clrMapOvr>
+</p:sld>
+</file>
+
+<file path=ppt/slides/slide2.xml><?xml version="1.0" encoding="utf-8"?>
+<p:sld xmlns:a="http://schemas.openxmlformats.org/drawingml/2006/main" xmlns:p="http://schemas.openxmlformats.org/presentationml/2006/main" xmlns:r="http://schemas.openxmlformats.org/officeDocument/2006/relationships">
+  <p:cSld>
+    <p:spTree>
+      <p:nvGrpSpPr>
+        <p:cNvPr id="1" name=""/>
+        <p:cNvGrpSpPr/>
+        <p:nvPr/>
+      </p:nvGrpSpPr>
+      <p:grpSpPr/>
+      <p:sp>
+        <p:nvSpPr>
+          <p:cNvPr id="2" name="Rectangle 1"/>
+          <p:cNvSpPr/>
+          <p:nvPr/>
+        </p:nvSpPr>
+        <p:spPr>
+          <a:xfrm>
+            <a:off x="0" y="0"/>
+            <a:ext cx="12192000" cy="6858000"/>
+          </a:xfrm>
+          <a:prstGeom prst="rect">
+            <a:avLst/>
+          </a:prstGeom>
+          <a:solidFill>
+            <a:srgbClr val="F8F6F2"/>
+          </a:solidFill>
+          <a:ln>
+            <a:noFill/>
+          </a:ln>
+          <a:effectLst/>
+        </p:spPr>
+        <p:style>
+          <a:lnRef idx="1">
+            <a:schemeClr val="accent1"/>
+          </a:lnRef>
+          <a:fillRef idx="3">
+            <a:schemeClr val="accent1"/>
+          </a:fillRef>
+          <a:effectRef idx="2">
+            <a:schemeClr val="accent1"/>
+          </a:effectRef>
+          <a:fontRef idx="minor">
+            <a:schemeClr val="lt1"/>
+          </a:fontRef>
+        </p:style>
+        <p:txBody>
+          <a:bodyPr rtlCol="0" anchor="ctr"/>
+          <a:lstStyle/>
+          <a:p>
+            <a:pPr algn="ctr"/>
+          </a:p>
+        </p:txBody>
+      </p:sp>
+      <p:sp>
+        <p:nvSpPr>
+          <p:cNvPr id="3" name="Rectangle 2"/>
+          <p:cNvSpPr/>
+          <p:nvPr/>
+        </p:nvSpPr>
+        <p:spPr>
+          <a:xfrm>
+            <a:off x="91440" y="121920"/>
+            <a:ext cx="11612880" cy="85344"/>
+          </a:xfrm>
+          <a:prstGeom prst="rect">
+            <a:avLst/>
+          </a:prstGeom>
+          <a:solidFill>
+            <a:srgbClr val="EE6A2C"/>
+          </a:solidFill>
+          <a:ln>
+            <a:noFill/>
+          </a:ln>
+          <a:effectLst/>
+        </p:spPr>
+        <p:style>
+          <a:lnRef idx="1">
+            <a:schemeClr val="accent1"/>
+          </a:lnRef>
+          <a:fillRef idx="3">
+            <a:schemeClr val="accent1"/>
+          </a:fillRef>
+          <a:effectRef idx="2">
+            <a:schemeClr val="accent1"/>
+          </a:effectRef>
+          <a:fontRef idx="minor">
+            <a:schemeClr val="lt1"/>
+          </a:fontRef>
+        </p:style>
+        <p:txBody>
+          <a:bodyPr rtlCol="0" anchor="ctr"/>
+          <a:lstStyle/>
+          <a:p>
+            <a:pPr algn="ctr"/>
+          </a:p>
+        </p:txBody>
+      </p:sp>
+      <p:sp>
+        <p:nvSpPr>
+          <p:cNvPr id="4" name="TextBox 3"/>
+          <p:cNvSpPr txBox="1"/>
+          <p:nvPr/>
+        </p:nvSpPr>
+        <p:spPr>
+          <a:xfrm>
+            <a:off x="579120" y="426720"/>
+            <a:ext cx="7315200" cy="182880"/>
+          </a:xfrm>
+          <a:prstGeom prst="rect">
+            <a:avLst/>
+          </a:prstGeom>
+          <a:noFill/>
+        </p:spPr>
+        <p:txBody>
+          <a:bodyPr wrap="square" anchor="t" lIns="0" rIns="0" tIns="0" bIns="0">
+            <a:spAutoFit/>
+          </a:bodyPr>
+          <a:lstStyle/>
+          <a:p>
+            <a:pPr algn="l"/>
+            <a:r>
+              <a:rPr sz="1300" b="1" i="0">
+                <a:solidFill>
+                  <a:srgbClr val="EE6A2C"/>
+                </a:solidFill>
+                <a:latin typeface="Arial"/>
+              </a:rPr>
+              <a:t>INSIGHTS QUALITATIFS · SEPTEMBRE 2026</a:t>
+            </a:r>
+          </a:p>
+        </p:txBody>
+      </p:sp>
+      <p:sp>
+        <p:nvSpPr>
+          <p:cNvPr id="5" name="TextBox 4"/>
+          <p:cNvSpPr txBox="1"/>
+          <p:nvPr/>
+        </p:nvSpPr>
+        <p:spPr>
+          <a:xfrm>
+            <a:off x="579120" y="609600"/>
+            <a:ext cx="7315200" cy="487680"/>
+          </a:xfrm>
+          <a:prstGeom prst="rect">
+            <a:avLst/>
+          </a:prstGeom>
+          <a:noFill/>
+        </p:spPr>
+        <p:txBody>
+          <a:bodyPr wrap="square" anchor="t" lIns="0" rIns="0" tIns="0" bIns="0">
+            <a:spAutoFit/>
+          </a:bodyPr>
+          <a:lstStyle/>
+          <a:p>
+            <a:pPr algn="l"/>
+            <a:r>
+              <a:rPr sz="3600" b="1" i="0">
+                <a:solidFill>
+                  <a:srgbClr val="111111"/>
+                </a:solidFill>
+                <a:latin typeface="Arial"/>
+              </a:rPr>
+              <a:t>Allo Pneus</a:t>
+            </a:r>
+          </a:p>
+        </p:txBody>
+      </p:sp>
+      <p:sp>
+        <p:nvSpPr>
+          <p:cNvPr id="6" name="TextBox 5"/>
+          <p:cNvSpPr txBox="1"/>
+          <p:nvPr/>
+        </p:nvSpPr>
+        <p:spPr>
+          <a:xfrm>
+            <a:off x="9144000" y="499872"/>
+            <a:ext cx="1889760" cy="182880"/>
+          </a:xfrm>
+          <a:prstGeom prst="rect">
+            <a:avLst/>
+          </a:prstGeom>
+          <a:noFill/>
+        </p:spPr>
+        <p:txBody>
+          <a:bodyPr wrap="square" anchor="t" lIns="0" rIns="0" tIns="0" bIns="0">
+            <a:spAutoFit/>
+          </a:bodyPr>
+          <a:lstStyle/>
+          <a:p>
+            <a:pPr algn="r"/>
+            <a:r>
+              <a:rPr sz="1500" b="1" i="0">
+                <a:solidFill>
+                  <a:srgbClr val="111111"/>
+                </a:solidFill>
+                <a:latin typeface="Arial"/>
+              </a:rPr>
+              <a:t>Lemrock</a:t>
+            </a:r>
+          </a:p>
+        </p:txBody>
+      </p:sp>
+      <p:sp>
+        <p:nvSpPr>
+          <p:cNvPr id="7" name="TextBox 6"/>
+          <p:cNvSpPr txBox="1"/>
+          <p:nvPr/>
+        </p:nvSpPr>
+        <p:spPr>
+          <a:xfrm>
+            <a:off x="579120" y="1219200"/>
+            <a:ext cx="9144000" cy="182880"/>
+          </a:xfrm>
+          <a:prstGeom prst="rect">
+            <a:avLst/>
+          </a:prstGeom>
+          <a:noFill/>
+        </p:spPr>
+        <p:txBody>
+          <a:bodyPr wrap="square" anchor="t" lIns="0" rIns="0" tIns="0" bIns="0">
+            <a:spAutoFit/>
+          </a:bodyPr>
+          <a:lstStyle/>
+          <a:p>
+            <a:pPr algn="l"/>
+            <a:r>
+              <a:rPr sz="1300" b="1" i="0">
+                <a:solidFill>
+                  <a:srgbClr val="EE6A2C"/>
+                </a:solidFill>
+                <a:latin typeface="Arial"/>
+              </a:rPr>
+              <a:t>OBJECTIF   </a:t>
+            </a:r>
+            <a:r>
+              <a:rPr sz="1300" b="0" i="0">
+                <a:solidFill>
+                  <a:srgbClr val="111111"/>
+                </a:solidFill>
+                <a:latin typeface="Arial"/>
+              </a:rPr>
+              <a:t>À définir</a:t>
+            </a:r>
+          </a:p>
+        </p:txBody>
+      </p:sp>
+      <p:sp>
+        <p:nvSpPr>
+          <p:cNvPr id="8" name="TextBox 7"/>
+          <p:cNvSpPr txBox="1"/>
+          <p:nvPr/>
+        </p:nvSpPr>
+        <p:spPr>
+          <a:xfrm>
+            <a:off x="579120" y="1524000"/>
+            <a:ext cx="4876800" cy="182880"/>
+          </a:xfrm>
+          <a:prstGeom prst="rect">
+            <a:avLst/>
+          </a:prstGeom>
+          <a:noFill/>
+        </p:spPr>
+        <p:txBody>
+          <a:bodyPr wrap="square" anchor="t" lIns="0" rIns="0" tIns="0" bIns="0">
+            <a:spAutoFit/>
+          </a:bodyPr>
+          <a:lstStyle/>
+          <a:p>
+            <a:pPr algn="l"/>
+            <a:r>
+              <a:rPr sz="1400" b="1" i="0">
+                <a:solidFill>
+                  <a:srgbClr val="555B66"/>
+                </a:solidFill>
+                <a:latin typeface="Arial"/>
+              </a:rPr>
+              <a:t>INSIGHTS QUALITATIFS</a:t>
+            </a:r>
+          </a:p>
+        </p:txBody>
+      </p:sp>
+      <p:sp>
+        <p:nvSpPr>
+          <p:cNvPr id="9" name="Rectangle 8"/>
+          <p:cNvSpPr/>
+          <p:nvPr/>
+        </p:nvSpPr>
+        <p:spPr>
+          <a:xfrm>
+            <a:off x="579120" y="1816608"/>
+            <a:ext cx="5071872" cy="2121408"/>
+          </a:xfrm>
+          <a:prstGeom prst="rect">
+            <a:avLst/>
+          </a:prstGeom>
+          <a:solidFill>
+            <a:srgbClr val="F6F7F9"/>
+          </a:solidFill>
+          <a:ln w="9525">
+            <a:solidFill>
+              <a:srgbClr val="E4E2DC"/>
+            </a:solidFill>
+          </a:ln>
+          <a:effectLst/>
+        </p:spPr>
+        <p:style>
+          <a:lnRef idx="1">
+            <a:schemeClr val="accent1"/>
+          </a:lnRef>
+          <a:fillRef idx="3">
+            <a:schemeClr val="accent1"/>
+          </a:fillRef>
+          <a:effectRef idx="2">
+            <a:schemeClr val="accent1"/>
+          </a:effectRef>
+          <a:fontRef idx="minor">
+            <a:schemeClr val="lt1"/>
+          </a:fontRef>
+        </p:style>
+        <p:txBody>
+          <a:bodyPr rtlCol="0" anchor="ctr"/>
+          <a:lstStyle/>
+          <a:p>
+            <a:pPr algn="ctr"/>
+          </a:p>
+        </p:txBody>
+      </p:sp>
+      <p:sp>
+        <p:nvSpPr>
+          <p:cNvPr id="10" name="TextBox 9"/>
+          <p:cNvSpPr txBox="1"/>
+          <p:nvPr/>
+        </p:nvSpPr>
+        <p:spPr>
+          <a:xfrm>
+            <a:off x="835152" y="2029968"/>
+            <a:ext cx="487680" cy="243840"/>
+          </a:xfrm>
+          <a:prstGeom prst="rect">
+            <a:avLst/>
+          </a:prstGeom>
+          <a:noFill/>
+        </p:spPr>
+        <p:txBody>
+          <a:bodyPr wrap="square" anchor="t" lIns="0" rIns="0" tIns="0" bIns="0">
+            <a:spAutoFit/>
+          </a:bodyPr>
+          <a:lstStyle/>
+          <a:p>
+            <a:pPr algn="l"/>
+            <a:r>
+              <a:rPr sz="2000" b="1" i="0">
+                <a:solidFill>
+                  <a:srgbClr val="EE6A2C"/>
+                </a:solidFill>
+                <a:latin typeface="Arial"/>
+              </a:rPr>
+              <a:t>01</a:t>
+            </a:r>
+          </a:p>
+        </p:txBody>
+      </p:sp>
+      <p:sp>
+        <p:nvSpPr>
+          <p:cNvPr id="11" name="TextBox 10"/>
+          <p:cNvSpPr txBox="1"/>
+          <p:nvPr/>
+        </p:nvSpPr>
+        <p:spPr>
+          <a:xfrm>
+            <a:off x="1383792" y="2048256"/>
+            <a:ext cx="4023360" cy="365760"/>
+          </a:xfrm>
+          <a:prstGeom prst="rect">
+            <a:avLst/>
+          </a:prstGeom>
+          <a:noFill/>
+        </p:spPr>
+        <p:txBody>
+          <a:bodyPr wrap="square" anchor="t" lIns="0" rIns="0" tIns="0" bIns="0">
+            <a:spAutoFit/>
+          </a:bodyPr>
+          <a:lstStyle/>
+          <a:p>
+            <a:pPr algn="l"/>
+            <a:r>
+              <a:rPr sz="1400" b="1" i="0">
+                <a:solidFill>
+                  <a:srgbClr val="111111"/>
+                </a:solidFill>
+                <a:latin typeface="Arial"/>
+              </a:rPr>
+              <a:t>Préparer dès maintenant la saison hiver</a:t>
+            </a:r>
+          </a:p>
+        </p:txBody>
+      </p:sp>
+      <p:sp>
+        <p:nvSpPr>
+          <p:cNvPr id="12" name="TextBox 11"/>
+          <p:cNvSpPr txBox="1"/>
+          <p:nvPr/>
+        </p:nvSpPr>
+        <p:spPr>
+          <a:xfrm>
+            <a:off x="835152" y="2609088"/>
+            <a:ext cx="4572000" cy="731520"/>
+          </a:xfrm>
+          <a:prstGeom prst="rect">
+            <a:avLst/>
+          </a:prstGeom>
+          <a:noFill/>
+        </p:spPr>
+        <p:txBody>
+          <a:bodyPr wrap="square" anchor="t" lIns="0" rIns="0" tIns="0" bIns="0">
+            <a:spAutoFit/>
+          </a:bodyPr>
+          <a:lstStyle/>
+          <a:p>
+            <a:pPr algn="l"/>
+            <a:r>
+              <a:rPr sz="1100" b="0" i="0">
+                <a:solidFill>
+                  <a:srgbClr val="555B66"/>
+                </a:solidFill>
+                <a:latin typeface="Arial"/>
+              </a:rPr>
+              <a:t>Pneus hiver et chaînes à neige pèsent 8,5 % des produits nommés en septembre. Les questions sur la loi montagne, le marquage 3PMSF et la comparaison Michelin Alpin / Continental WinterContact se multiplient.</a:t>
+            </a:r>
+          </a:p>
+        </p:txBody>
+      </p:sp>
+      <p:sp>
+        <p:nvSpPr>
+          <p:cNvPr id="13" name="TextBox 12"/>
+          <p:cNvSpPr txBox="1"/>
+          <p:nvPr/>
+        </p:nvSpPr>
+        <p:spPr>
+          <a:xfrm>
+            <a:off x="835152" y="3310128"/>
+            <a:ext cx="4572000" cy="487680"/>
+          </a:xfrm>
+          <a:prstGeom prst="rect">
+            <a:avLst/>
+          </a:prstGeom>
+          <a:noFill/>
+        </p:spPr>
+        <p:txBody>
+          <a:bodyPr wrap="square" anchor="t" lIns="0" rIns="0" tIns="0" bIns="0">
+            <a:spAutoFit/>
+          </a:bodyPr>
+          <a:lstStyle/>
+          <a:p>
+            <a:pPr algn="l"/>
+            <a:r>
+              <a:rPr sz="900" b="1" i="0">
+                <a:solidFill>
+                  <a:srgbClr val="555B66"/>
+                </a:solidFill>
+                <a:latin typeface="Arial"/>
+              </a:rPr>
+              <a:t>→  Lancer des messages hiver dès octobre : conformité loi montagne, comparatifs de modèles, montage avant les premiers froids.</a:t>
+            </a:r>
+          </a:p>
+        </p:txBody>
+      </p:sp>
+      <p:sp>
+        <p:nvSpPr>
+          <p:cNvPr id="14" name="Rectangle 13"/>
+          <p:cNvSpPr/>
+          <p:nvPr/>
+        </p:nvSpPr>
+        <p:spPr>
+          <a:xfrm>
+            <a:off x="5992368" y="1816608"/>
+            <a:ext cx="5071872" cy="2121408"/>
+          </a:xfrm>
+          <a:prstGeom prst="rect">
+            <a:avLst/>
+          </a:prstGeom>
+          <a:solidFill>
+            <a:srgbClr val="F6F7F9"/>
+          </a:solidFill>
+          <a:ln w="9525">
+            <a:solidFill>
+              <a:srgbClr val="E4E2DC"/>
+            </a:solidFill>
+          </a:ln>
+          <a:effectLst/>
+        </p:spPr>
+        <p:style>
+          <a:lnRef idx="1">
+            <a:schemeClr val="accent1"/>
+          </a:lnRef>
+          <a:fillRef idx="3">
+            <a:schemeClr val="accent1"/>
+          </a:fillRef>
+          <a:effectRef idx="2">
+            <a:schemeClr val="accent1"/>
+          </a:effectRef>
+          <a:fontRef idx="minor">
+            <a:schemeClr val="lt1"/>
+          </a:fontRef>
+        </p:style>
+        <p:txBody>
+          <a:bodyPr rtlCol="0" anchor="ctr"/>
+          <a:lstStyle/>
+          <a:p>
+            <a:pPr algn="ctr"/>
+          </a:p>
+        </p:txBody>
+      </p:sp>
+      <p:sp>
+        <p:nvSpPr>
+          <p:cNvPr id="15" name="TextBox 14"/>
+          <p:cNvSpPr txBox="1"/>
+          <p:nvPr/>
+        </p:nvSpPr>
+        <p:spPr>
+          <a:xfrm>
+            <a:off x="6248400" y="2029968"/>
+            <a:ext cx="487680" cy="243840"/>
+          </a:xfrm>
+          <a:prstGeom prst="rect">
+            <a:avLst/>
+          </a:prstGeom>
+          <a:noFill/>
+        </p:spPr>
+        <p:txBody>
+          <a:bodyPr wrap="square" anchor="t" lIns="0" rIns="0" tIns="0" bIns="0">
+            <a:spAutoFit/>
+          </a:bodyPr>
+          <a:lstStyle/>
+          <a:p>
+            <a:pPr algn="l"/>
+            <a:r>
+              <a:rPr sz="2000" b="1" i="0">
+                <a:solidFill>
+                  <a:srgbClr val="EE6A2C"/>
+                </a:solidFill>
+                <a:latin typeface="Arial"/>
+              </a:rPr>
+              <a:t>02</a:t>
+            </a:r>
+          </a:p>
+        </p:txBody>
+      </p:sp>
+      <p:sp>
+        <p:nvSpPr>
+          <p:cNvPr id="16" name="TextBox 15"/>
+          <p:cNvSpPr txBox="1"/>
+          <p:nvPr/>
+        </p:nvSpPr>
+        <p:spPr>
+          <a:xfrm>
+            <a:off x="6797040" y="2048256"/>
+            <a:ext cx="4023360" cy="365760"/>
+          </a:xfrm>
+          <a:prstGeom prst="rect">
+            <a:avLst/>
+          </a:prstGeom>
+          <a:noFill/>
+        </p:spPr>
+        <p:txBody>
+          <a:bodyPr wrap="square" anchor="t" lIns="0" rIns="0" tIns="0" bIns="0">
+            <a:spAutoFit/>
+          </a:bodyPr>
+          <a:lstStyle/>
+          <a:p>
+            <a:pPr algn="l"/>
+            <a:r>
+              <a:rPr sz="1400" b="1" i="0">
+                <a:solidFill>
+                  <a:srgbClr val="111111"/>
+                </a:solidFill>
+                <a:latin typeface="Arial"/>
+              </a:rPr>
+              <a:t>Cibler les conducteurs de voitures électriques</a:t>
+            </a:r>
+          </a:p>
+        </p:txBody>
+      </p:sp>
+      <p:sp>
+        <p:nvSpPr>
+          <p:cNvPr id="17" name="TextBox 16"/>
+          <p:cNvSpPr txBox="1"/>
+          <p:nvPr/>
+        </p:nvSpPr>
+        <p:spPr>
+          <a:xfrm>
+            <a:off x="6248400" y="2609088"/>
+            <a:ext cx="4572000" cy="731520"/>
+          </a:xfrm>
+          <a:prstGeom prst="rect">
+            <a:avLst/>
+          </a:prstGeom>
+          <a:noFill/>
+        </p:spPr>
+        <p:txBody>
+          <a:bodyPr wrap="square" anchor="t" lIns="0" rIns="0" tIns="0" bIns="0">
+            <a:spAutoFit/>
+          </a:bodyPr>
+          <a:lstStyle/>
+          <a:p>
+            <a:pPr algn="l"/>
+            <a:r>
+              <a:rPr sz="1100" b="0" i="0">
+                <a:solidFill>
+                  <a:srgbClr val="555B66"/>
+                </a:solidFill>
+                <a:latin typeface="Arial"/>
+              </a:rPr>
+              <a:t>De nombreuses requêtes citent un modèle électrique (Zoé 2020, MG4 EV Urban) ou s'interrogent sur l'impact des pneus ou des jantes sur l'autonomie.</a:t>
+            </a:r>
+          </a:p>
+        </p:txBody>
+      </p:sp>
+      <p:sp>
+        <p:nvSpPr>
+          <p:cNvPr id="18" name="TextBox 17"/>
+          <p:cNvSpPr txBox="1"/>
+          <p:nvPr/>
+        </p:nvSpPr>
+        <p:spPr>
+          <a:xfrm>
+            <a:off x="6248400" y="3310128"/>
+            <a:ext cx="4572000" cy="487680"/>
+          </a:xfrm>
+          <a:prstGeom prst="rect">
+            <a:avLst/>
+          </a:prstGeom>
+          <a:noFill/>
+        </p:spPr>
+        <p:txBody>
+          <a:bodyPr wrap="square" anchor="t" lIns="0" rIns="0" tIns="0" bIns="0">
+            <a:spAutoFit/>
+          </a:bodyPr>
+          <a:lstStyle/>
+          <a:p>
+            <a:pPr algn="l"/>
+            <a:r>
+              <a:rPr sz="900" b="1" i="0">
+                <a:solidFill>
+                  <a:srgbClr val="555B66"/>
+                </a:solidFill>
+                <a:latin typeface="Arial"/>
+              </a:rPr>
+              <a:t>→  Créer une campagne dédiée « pneus VE » : autonomie, silence de roulement et dimensions compatibles par modèle.</a:t>
+            </a:r>
+          </a:p>
+        </p:txBody>
+      </p:sp>
+      <p:sp>
+        <p:nvSpPr>
+          <p:cNvPr id="19" name="Rectangle 18"/>
+          <p:cNvSpPr/>
+          <p:nvPr/>
+        </p:nvSpPr>
+        <p:spPr>
+          <a:xfrm>
+            <a:off x="579120" y="4133088"/>
+            <a:ext cx="5071872" cy="2121408"/>
+          </a:xfrm>
+          <a:prstGeom prst="rect">
+            <a:avLst/>
+          </a:prstGeom>
+          <a:solidFill>
+            <a:srgbClr val="F6F7F9"/>
+          </a:solidFill>
+          <a:ln w="9525">
+            <a:solidFill>
+              <a:srgbClr val="E4E2DC"/>
+            </a:solidFill>
+          </a:ln>
+          <a:effectLst/>
+        </p:spPr>
+        <p:style>
+          <a:lnRef idx="1">
+            <a:schemeClr val="accent1"/>
+          </a:lnRef>
+          <a:fillRef idx="3">
+            <a:schemeClr val="accent1"/>
+          </a:fillRef>
+          <a:effectRef idx="2">
+            <a:schemeClr val="accent1"/>
+          </a:effectRef>
+          <a:fontRef idx="minor">
+            <a:schemeClr val="lt1"/>
+          </a:fontRef>
+        </p:style>
+        <p:txBody>
+          <a:bodyPr rtlCol="0" anchor="ctr"/>
+          <a:lstStyle/>
+          <a:p>
+            <a:pPr algn="ctr"/>
+          </a:p>
+        </p:txBody>
+      </p:sp>
+      <p:sp>
+        <p:nvSpPr>
+          <p:cNvPr id="20" name="TextBox 19"/>
+          <p:cNvSpPr txBox="1"/>
+          <p:nvPr/>
+        </p:nvSpPr>
+        <p:spPr>
+          <a:xfrm>
+            <a:off x="835152" y="4346448"/>
+            <a:ext cx="487680" cy="243840"/>
+          </a:xfrm>
+          <a:prstGeom prst="rect">
+            <a:avLst/>
+          </a:prstGeom>
+          <a:noFill/>
+        </p:spPr>
+        <p:txBody>
+          <a:bodyPr wrap="square" anchor="t" lIns="0" rIns="0" tIns="0" bIns="0">
+            <a:spAutoFit/>
+          </a:bodyPr>
+          <a:lstStyle/>
+          <a:p>
+            <a:pPr algn="l"/>
+            <a:r>
+              <a:rPr sz="2000" b="1" i="0">
+                <a:solidFill>
+                  <a:srgbClr val="EE6A2C"/>
+                </a:solidFill>
+                <a:latin typeface="Arial"/>
+              </a:rPr>
+              <a:t>03</a:t>
+            </a:r>
+          </a:p>
+        </p:txBody>
+      </p:sp>
+      <p:sp>
+        <p:nvSpPr>
+          <p:cNvPr id="21" name="TextBox 20"/>
+          <p:cNvSpPr txBox="1"/>
+          <p:nvPr/>
+        </p:nvSpPr>
+        <p:spPr>
+          <a:xfrm>
+            <a:off x="1383792" y="4364736"/>
+            <a:ext cx="4023360" cy="365760"/>
+          </a:xfrm>
+          <a:prstGeom prst="rect">
+            <a:avLst/>
+          </a:prstGeom>
+          <a:noFill/>
+        </p:spPr>
+        <p:txBody>
+          <a:bodyPr wrap="square" anchor="t" lIns="0" rIns="0" tIns="0" bIns="0">
+            <a:spAutoFit/>
+          </a:bodyPr>
+          <a:lstStyle/>
+          <a:p>
+            <a:pPr algn="l"/>
+            <a:r>
+              <a:rPr sz="1400" b="1" i="0">
+                <a:solidFill>
+                  <a:srgbClr val="111111"/>
+                </a:solidFill>
+                <a:latin typeface="Arial"/>
+              </a:rPr>
+              <a:t>Transformer la visibilité payante en recommandation spontanée</a:t>
+            </a:r>
+          </a:p>
+        </p:txBody>
+      </p:sp>
+      <p:sp>
+        <p:nvSpPr>
+          <p:cNvPr id="22" name="TextBox 21"/>
+          <p:cNvSpPr txBox="1"/>
+          <p:nvPr/>
+        </p:nvSpPr>
+        <p:spPr>
+          <a:xfrm>
+            <a:off x="835152" y="4925568"/>
+            <a:ext cx="4572000" cy="731520"/>
+          </a:xfrm>
+          <a:prstGeom prst="rect">
+            <a:avLst/>
+          </a:prstGeom>
+          <a:noFill/>
+        </p:spPr>
+        <p:txBody>
+          <a:bodyPr wrap="square" anchor="t" lIns="0" rIns="0" tIns="0" bIns="0">
+            <a:spAutoFit/>
+          </a:bodyPr>
+          <a:lstStyle/>
+          <a:p>
+            <a:pPr algn="l"/>
+            <a:r>
+              <a:rPr sz="1100" b="0" i="0">
+                <a:solidFill>
+                  <a:srgbClr val="555B66"/>
+                </a:solidFill>
+                <a:latin typeface="Arial"/>
+              </a:rPr>
+              <a:t>Allo Pneus passe à 7,0 % de part de voix (+5,7 pts, 5e enseigne) et 21,3 % côté ads (+7,0 pts), mais reste sous 0,1 % dans les recommandations spontanées des IA, loin de Michelin et Norauto.</a:t>
+            </a:r>
+          </a:p>
+        </p:txBody>
+      </p:sp>
+      <p:sp>
+        <p:nvSpPr>
+          <p:cNvPr id="23" name="TextBox 22"/>
+          <p:cNvSpPr txBox="1"/>
+          <p:nvPr/>
+        </p:nvSpPr>
+        <p:spPr>
+          <a:xfrm>
+            <a:off x="835152" y="5626608"/>
+            <a:ext cx="4572000" cy="487680"/>
+          </a:xfrm>
+          <a:prstGeom prst="rect">
+            <a:avLst/>
+          </a:prstGeom>
+          <a:noFill/>
+        </p:spPr>
+        <p:txBody>
+          <a:bodyPr wrap="square" anchor="t" lIns="0" rIns="0" tIns="0" bIns="0">
+            <a:spAutoFit/>
+          </a:bodyPr>
+          <a:lstStyle/>
+          <a:p>
+            <a:pPr algn="l"/>
+            <a:r>
+              <a:rPr sz="900" b="1" i="0">
+                <a:solidFill>
+                  <a:srgbClr val="555B66"/>
+                </a:solidFill>
+                <a:latin typeface="Arial"/>
+              </a:rPr>
+              <a:t>→  Maintenir la pression publicitaire et enrichir les contenus de marque (guides, fiches produits) pour être cité sans être nommé.</a:t>
+            </a:r>
+          </a:p>
+        </p:txBody>
+      </p:sp>
+      <p:sp>
+        <p:nvSpPr>
+          <p:cNvPr id="24" name="Rectangle 23"/>
+          <p:cNvSpPr/>
+          <p:nvPr/>
+        </p:nvSpPr>
+        <p:spPr>
+          <a:xfrm>
+            <a:off x="5992368" y="4133088"/>
+            <a:ext cx="5071872" cy="2121408"/>
+          </a:xfrm>
+          <a:prstGeom prst="rect">
+            <a:avLst/>
+          </a:prstGeom>
+          <a:solidFill>
+            <a:srgbClr val="F6F7F9"/>
+          </a:solidFill>
+          <a:ln w="9525">
+            <a:solidFill>
+              <a:srgbClr val="E4E2DC"/>
+            </a:solidFill>
+          </a:ln>
+          <a:effectLst/>
+        </p:spPr>
+        <p:style>
+          <a:lnRef idx="1">
+            <a:schemeClr val="accent1"/>
+          </a:lnRef>
+          <a:fillRef idx="3">
+            <a:schemeClr val="accent1"/>
+          </a:fillRef>
+          <a:effectRef idx="2">
+            <a:schemeClr val="accent1"/>
+          </a:effectRef>
+          <a:fontRef idx="minor">
+            <a:schemeClr val="lt1"/>
+          </a:fontRef>
+        </p:style>
+        <p:txBody>
+          <a:bodyPr rtlCol="0" anchor="ctr"/>
+          <a:lstStyle/>
+          <a:p>
+            <a:pPr algn="ctr"/>
+          </a:p>
+        </p:txBody>
+      </p:sp>
+      <p:sp>
+        <p:nvSpPr>
+          <p:cNvPr id="25" name="TextBox 24"/>
+          <p:cNvSpPr txBox="1"/>
+          <p:nvPr/>
+        </p:nvSpPr>
+        <p:spPr>
+          <a:xfrm>
+            <a:off x="6248400" y="4346448"/>
+            <a:ext cx="487680" cy="243840"/>
+          </a:xfrm>
+          <a:prstGeom prst="rect">
+            <a:avLst/>
+          </a:prstGeom>
+          <a:noFill/>
+        </p:spPr>
+        <p:txBody>
+          <a:bodyPr wrap="square" anchor="t" lIns="0" rIns="0" tIns="0" bIns="0">
+            <a:spAutoFit/>
+          </a:bodyPr>
+          <a:lstStyle/>
+          <a:p>
+            <a:pPr algn="l"/>
+            <a:r>
+              <a:rPr sz="2000" b="1" i="0">
+                <a:solidFill>
+                  <a:srgbClr val="EE6A2C"/>
+                </a:solidFill>
+                <a:latin typeface="Arial"/>
+              </a:rPr>
+              <a:t>04</a:t>
+            </a:r>
+          </a:p>
+        </p:txBody>
+      </p:sp>
+      <p:sp>
+        <p:nvSpPr>
+          <p:cNvPr id="26" name="TextBox 25"/>
+          <p:cNvSpPr txBox="1"/>
+          <p:nvPr/>
+        </p:nvSpPr>
+        <p:spPr>
+          <a:xfrm>
+            <a:off x="6797040" y="4364736"/>
+            <a:ext cx="4023360" cy="365760"/>
+          </a:xfrm>
+          <a:prstGeom prst="rect">
+            <a:avLst/>
+          </a:prstGeom>
+          <a:noFill/>
+        </p:spPr>
+        <p:txBody>
+          <a:bodyPr wrap="square" anchor="t" lIns="0" rIns="0" tIns="0" bIns="0">
+            <a:spAutoFit/>
+          </a:bodyPr>
+          <a:lstStyle/>
+          <a:p>
+            <a:pPr algn="l"/>
+            <a:r>
+              <a:rPr sz="1400" b="1" i="0">
+                <a:solidFill>
+                  <a:srgbClr val="111111"/>
+                </a:solidFill>
+                <a:latin typeface="Arial"/>
+              </a:rPr>
+              <a:t>Répondre à des questions plus longues et plus précises</a:t>
+            </a:r>
+          </a:p>
+        </p:txBody>
+      </p:sp>
+      <p:sp>
+        <p:nvSpPr>
+          <p:cNvPr id="27" name="TextBox 26"/>
+          <p:cNvSpPr txBox="1"/>
+          <p:nvPr/>
+        </p:nvSpPr>
+        <p:spPr>
+          <a:xfrm>
+            <a:off x="6248400" y="4925568"/>
+            <a:ext cx="4572000" cy="731520"/>
+          </a:xfrm>
+          <a:prstGeom prst="rect">
+            <a:avLst/>
+          </a:prstGeom>
+          <a:noFill/>
+        </p:spPr>
+        <p:txBody>
+          <a:bodyPr wrap="square" anchor="t" lIns="0" rIns="0" tIns="0" bIns="0">
+            <a:spAutoFit/>
+          </a:bodyPr>
+          <a:lstStyle/>
+          <a:p>
+            <a:pPr algn="l"/>
+            <a:r>
+              <a:rPr sz="1100" b="0" i="0">
+                <a:solidFill>
+                  <a:srgbClr val="555B66"/>
+                </a:solidFill>
+                <a:latin typeface="Arial"/>
+              </a:rPr>
+              <a:t>Les requêtes shopping passent à 12,5 mots en moyenne (+42,7 %). Trois conversations sur quatre sont déclenchées par l'achat d'une voiture. Le CTR passe de 0,15 % à 0,40 % sur le mois.</a:t>
+            </a:r>
+          </a:p>
+        </p:txBody>
+      </p:sp>
+      <p:sp>
+        <p:nvSpPr>
+          <p:cNvPr id="28" name="TextBox 27"/>
+          <p:cNvSpPr txBox="1"/>
+          <p:nvPr/>
+        </p:nvSpPr>
+        <p:spPr>
+          <a:xfrm>
+            <a:off x="6248400" y="5626608"/>
+            <a:ext cx="4572000" cy="487680"/>
+          </a:xfrm>
+          <a:prstGeom prst="rect">
+            <a:avLst/>
+          </a:prstGeom>
+          <a:noFill/>
+        </p:spPr>
+        <p:txBody>
+          <a:bodyPr wrap="square" anchor="t" lIns="0" rIns="0" tIns="0" bIns="0">
+            <a:spAutoFit/>
+          </a:bodyPr>
+          <a:lstStyle/>
+          <a:p>
+            <a:pPr algn="l"/>
+            <a:r>
+              <a:rPr sz="900" b="1" i="0">
+                <a:solidFill>
+                  <a:srgbClr val="555B66"/>
+                </a:solidFill>
+                <a:latin typeface="Arial"/>
+              </a:rPr>
+              <a:t>→  Décliner les accroches par véhicule et par dimension : « Quels pneus pour votre nouvelle voiture ? », puis la référence adaptée.</a:t>
+            </a:r>
           </a:p>
         </p:txBody>
       </p:sp>

</xml_diff>

<commit_message>
Allo Pneus : slides refaites, cohérentes avec le catalogue produits
Co-Authored-By: Claude Opus 5.5 <noreply@anthropic.com>
Claude-Session: https://claude.ai/code/session_01BmxtdWjbeRUyPx9e1qVLbT
</commit_message>
<xml_diff>
--- a/rapports/septembre/Allo_Pneus_sept2026.pptx
+++ b/rapports/septembre/Allo_Pneus_sept2026.pptx
@@ -5289,7 +5289,7 @@
                 </a:solidFill>
                 <a:latin typeface="Arial"/>
               </a:rPr>
-              <a:t>pneu hiver</a:t>
+              <a:t>toutes saisons</a:t>
             </a:r>
             <a:r>
               <a:rPr sz="1800" b="1" i="0">
@@ -5298,7 +5298,7 @@
                 </a:solidFill>
                 <a:latin typeface="Arial"/>
               </a:rPr>
-              <a:t>    jante</a:t>
+              <a:t>    3PMSF</a:t>
             </a:r>
           </a:p>
           <a:p>
@@ -5314,7 +5314,7 @@
                 </a:solidFill>
                 <a:latin typeface="Arial"/>
               </a:rPr>
-              <a:t>3PMSF</a:t>
+              <a:t>loi montagne</a:t>
             </a:r>
             <a:r>
               <a:rPr sz="1400" b="1" i="0">
@@ -5323,7 +5323,7 @@
                 </a:solidFill>
                 <a:latin typeface="Arial"/>
               </a:rPr>
-              <a:t>    roue de secours</a:t>
+              <a:t>    freinage</a:t>
             </a:r>
           </a:p>
           <a:p>
@@ -5339,7 +5339,7 @@
                 </a:solidFill>
                 <a:latin typeface="Arial"/>
               </a:rPr>
-              <a:t>voiture électrique</a:t>
+              <a:t>pas chers</a:t>
             </a:r>
             <a:r>
               <a:rPr sz="1300" b="0" i="0">
@@ -5348,7 +5348,7 @@
                 </a:solidFill>
                 <a:latin typeface="Arial"/>
               </a:rPr>
-              <a:t>    freinage</a:t>
+              <a:t>    sûrs</a:t>
             </a:r>
           </a:p>
           <a:p>
@@ -5364,7 +5364,7 @@
                 </a:solidFill>
                 <a:latin typeface="Arial"/>
               </a:rPr>
-              <a:t>Michelin Alpin</a:t>
+              <a:t>voiture électrique</a:t>
             </a:r>
             <a:r>
               <a:rPr sz="1200" b="1" i="0">
@@ -5373,7 +5373,7 @@
                 </a:solidFill>
                 <a:latin typeface="Arial"/>
               </a:rPr>
-              <a:t>    loi montagne</a:t>
+              <a:t>    MG4 EV</a:t>
             </a:r>
           </a:p>
           <a:p>
@@ -5389,7 +5389,25 @@
                 </a:solidFill>
                 <a:latin typeface="Arial"/>
               </a:rPr>
-              <a:t>Continental WinterContact</a:t>
+              <a:t>Zoé</a:t>
+            </a:r>
+            <a:r>
+              <a:rPr sz="1100" b="0" i="0">
+                <a:solidFill>
+                  <a:srgbClr val="555B66"/>
+                </a:solidFill>
+                <a:latin typeface="Arial"/>
+              </a:rPr>
+              <a:t>    pneus hiver</a:t>
+            </a:r>
+            <a:r>
+              <a:rPr sz="1100" b="1" i="0">
+                <a:solidFill>
+                  <a:srgbClr val="EE6A2C"/>
+                </a:solidFill>
+                <a:latin typeface="Arial"/>
+              </a:rPr>
+              <a:t>    chaînes à neige</a:t>
             </a:r>
           </a:p>
           <a:p>
@@ -5401,11 +5419,11 @@
             <a:r>
               <a:rPr sz="1100" b="1" i="0">
                 <a:solidFill>
-                  <a:srgbClr val="EE6A2C"/>
-                </a:solidFill>
-                <a:latin typeface="Arial"/>
-              </a:rPr>
-              <a:t>chaînes à neige</a:t>
+                  <a:srgbClr val="111111"/>
+                </a:solidFill>
+                <a:latin typeface="Arial"/>
+              </a:rPr>
+              <a:t>dimensions</a:t>
             </a:r>
             <a:r>
               <a:rPr sz="1100" b="0" i="0">
@@ -5414,32 +5432,7 @@
                 </a:solidFill>
                 <a:latin typeface="Arial"/>
               </a:rPr>
-              <a:t>    autonomie</a:t>
-            </a:r>
-          </a:p>
-          <a:p>
-            <a:pPr algn="l">
-              <a:spcAft>
-                <a:spcPts val="500"/>
-              </a:spcAft>
-            </a:pPr>
-            <a:r>
-              <a:rPr sz="1100" b="1" i="0">
-                <a:solidFill>
-                  <a:srgbClr val="111111"/>
-                </a:solidFill>
-                <a:latin typeface="Arial"/>
-              </a:rPr>
-              <a:t>kit anti-crevaison</a:t>
-            </a:r>
-            <a:r>
-              <a:rPr sz="1100" b="0" i="0">
-                <a:solidFill>
-                  <a:srgbClr val="555B66"/>
-                </a:solidFill>
-                <a:latin typeface="Arial"/>
-              </a:rPr>
-              <a:t>    toutes saisons</a:t>
+              <a:t>    Continental</a:t>
             </a:r>
           </a:p>
         </p:txBody>
@@ -5737,7 +5730,7 @@
                 </a:solidFill>
                 <a:latin typeface="Arial"/>
               </a:rPr>
-              <a:t>Quels pneus VE recommandez-vous pour une Zoé 2020 ?</a:t>
+              <a:t>Comment savoir si mes pneus toutes saisons suffisent pour la loi montagne ?</a:t>
             </a:r>
           </a:p>
         </p:txBody>
@@ -5851,7 +5844,7 @@
                 </a:solidFill>
                 <a:latin typeface="Arial"/>
               </a:rPr>
-              <a:t>Peux-tu comparer Michelin Alpin 7 et Continental WinterContact TS870 ?</a:t>
+              <a:t>Quels modèles 3PMSF recommandes-tu pour la MG4 EV Urban en 2026 ?</a:t>
             </a:r>
           </a:p>
         </p:txBody>
@@ -5965,7 +5958,7 @@
                 </a:solidFill>
                 <a:latin typeface="Arial"/>
               </a:rPr>
-              <a:t>Chaînes, chaussettes ou pneus hiver : quoi privilégier ?</a:t>
+              <a:t>Quels pneus recommanderais-tu pour améliorer les distances de freinage à 130 km/h ?</a:t>
             </a:r>
           </a:p>
         </p:txBody>
@@ -6079,7 +6072,7 @@
                 </a:solidFill>
                 <a:latin typeface="Arial"/>
               </a:rPr>
-              <a:t>Mes pneus toutes saisons suffisent-ils pour la loi montagne ?</a:t>
+              <a:t>Quels pneus VE recommandez-vous pour une Zoé 2020 ?</a:t>
             </a:r>
           </a:p>
         </p:txBody>
@@ -7363,7 +7356,7 @@
                 </a:solidFill>
                 <a:latin typeface="Arial"/>
               </a:rPr>
-              <a:t>Préparer dès maintenant la saison hiver</a:t>
+              <a:t>Présenter le 4 saisons comme la réponse à l'hiver</a:t>
             </a:r>
           </a:p>
         </p:txBody>
@@ -7398,7 +7391,7 @@
                 </a:solidFill>
                 <a:latin typeface="Arial"/>
               </a:rPr>
-              <a:t>Pneus hiver et chaînes à neige pèsent 8,5 % des produits nommés en septembre. Les questions sur la loi montagne, le marquage 3PMSF et la comparaison Michelin Alpin / Continental WinterContact se multiplient.</a:t>
+              <a:t>Pneus hiver et chaînes à neige pèsent 8,5 % des produits nommés, avec des questions sur la loi montagne et le 3PMSF. Or 30 des 47 références du catalogue sont des pneus 4 saisons certifiés 3PMSF (Continental, Dunlop, Falken).</a:t>
             </a:r>
           </a:p>
         </p:txBody>
@@ -7433,7 +7426,7 @@
                 </a:solidFill>
                 <a:latin typeface="Arial"/>
               </a:rPr>
-              <a:t>→  Lancer des messages hiver dès octobre : conformité loi montagne, comparatifs de modèles, montage avant les premiers froids.</a:t>
+              <a:t>→  Accroche type : « Pneus 4 saisons 3PMSF : conformes à la loi montagne, sans changer de pneus à chaque saison ».</a:t>
             </a:r>
           </a:p>
         </p:txBody>
@@ -7549,7 +7542,7 @@
                 </a:solidFill>
                 <a:latin typeface="Arial"/>
               </a:rPr>
-              <a:t>Cibler les conducteurs de voitures électriques</a:t>
+              <a:t>Rassurer sur le rapport sécurité / prix</a:t>
             </a:r>
           </a:p>
         </p:txBody>
@@ -7584,7 +7577,7 @@
                 </a:solidFill>
                 <a:latin typeface="Arial"/>
               </a:rPr>
-              <a:t>De nombreuses requêtes citent un modèle électrique (Zoé 2020, MG4 EV Urban) ou s'interrogent sur l'impact des pneus ou des jantes sur l'autonomie.</a:t>
+              <a:t>Les requêtes associent prix et sécurité (« pas chers mais sûrs », distances de freinage à 130 km/h). Le catalogue va de 52 € à 249 € le pneu, avec des marques premium (Continental, Bridgestone, Dunlop).</a:t>
             </a:r>
           </a:p>
         </p:txBody>
@@ -7619,7 +7612,7 @@
                 </a:solidFill>
                 <a:latin typeface="Arial"/>
               </a:rPr>
-              <a:t>→  Créer une campagne dédiée « pneus VE » : autonomie, silence de roulement et dimensions compatibles par modèle.</a:t>
+              <a:t>→  Mettre en avant les marques premium à prix accessible et les étiquettes européennes (freinage sur sol mouillé, bruit).</a:t>
             </a:r>
           </a:p>
         </p:txBody>
@@ -7735,7 +7728,7 @@
                 </a:solidFill>
                 <a:latin typeface="Arial"/>
               </a:rPr>
-              <a:t>Transformer la visibilité payante en recommandation spontanée</a:t>
+              <a:t>Répondre aux conducteurs de voitures électriques</a:t>
             </a:r>
           </a:p>
         </p:txBody>
@@ -7770,7 +7763,7 @@
                 </a:solidFill>
                 <a:latin typeface="Arial"/>
               </a:rPr>
-              <a:t>Allo Pneus passe à 7,0 % de part de voix (+5,7 pts, 5e enseigne) et 21,3 % côté ads (+7,0 pts), mais reste sous 0,1 % dans les recommandations spontanées des IA, loin de Michelin et Norauto.</a:t>
+              <a:t>Plusieurs requêtes citent un modèle électrique (MG4 EV, Zoé 2020) et cherchent des pneus adaptés ou certifiés 3PMSF.</a:t>
             </a:r>
           </a:p>
         </p:txBody>
@@ -7805,7 +7798,7 @@
                 </a:solidFill>
                 <a:latin typeface="Arial"/>
               </a:rPr>
-              <a:t>→  Maintenir la pression publicitaire et enrichir les contenus de marque (guides, fiches produits) pour être cité sans être nommé.</a:t>
+              <a:t>→  Proposer les dimensions compatibles avec ces modèles et mettre en avant le silence de roulement et l'adhérence.</a:t>
             </a:r>
           </a:p>
         </p:txBody>
@@ -7921,7 +7914,7 @@
                 </a:solidFill>
                 <a:latin typeface="Arial"/>
               </a:rPr>
-              <a:t>Répondre à des questions plus longues et plus précises</a:t>
+              <a:t>Une visibilité en forte hausse</a:t>
             </a:r>
           </a:p>
         </p:txBody>
@@ -7956,7 +7949,7 @@
                 </a:solidFill>
                 <a:latin typeface="Arial"/>
               </a:rPr>
-              <a:t>Les requêtes shopping passent à 12,5 mots en moyenne (+42,7 %). Trois conversations sur quatre sont déclenchées par l'achat d'une voiture. Le CTR passe de 0,15 % à 0,40 % sur le mois.</a:t>
+              <a:t>Allo Pneus passe à 7,0 % de part de voix (+5,7 pts) et 21,3 % côté ads (+7,0 pts). Le CTR passe de 0,15 % à 0,40 % malgré l'arrêt de diffusion du 10 au 14/09.</a:t>
             </a:r>
           </a:p>
         </p:txBody>
@@ -7991,7 +7984,7 @@
                 </a:solidFill>
                 <a:latin typeface="Arial"/>
               </a:rPr>
-              <a:t>→  Décliner les accroches par véhicule et par dimension : « Quels pneus pour votre nouvelle voiture ? », puis la référence adaptée.</a:t>
+              <a:t>→  Maintenir la pression ads en octobre, au cœur de la saison du changement de pneus.</a:t>
             </a:r>
           </a:p>
         </p:txBody>

</xml_diff>

<commit_message>
Allo Pneus : insights et catégories depuis le fichier ads CTR septembre
Co-Authored-By: Claude Opus 5.5 <noreply@anthropic.com>
Claude-Session: https://claude.ai/code/session_01BmxtdWjbeRUyPx9e1qVLbT
</commit_message>
<xml_diff>
--- a/rapports/septembre/Allo_Pneus_sept2026.pptx
+++ b/rapports/septembre/Allo_Pneus_sept2026.pptx
@@ -6335,7 +6335,7 @@
                 </a:solidFill>
                 <a:latin typeface="Arial"/>
               </a:rPr>
-              <a:t>Pneus toutes saisons · 2 %</a:t>
+              <a:t>Pneus SUV et utilitaires · 39 %</a:t>
             </a:r>
           </a:p>
         </p:txBody>
@@ -6414,7 +6414,7 @@
                 </a:solidFill>
                 <a:latin typeface="Arial"/>
               </a:rPr>
-              <a:t>Accessoires et entretien · 8 %</a:t>
+              <a:t>Pneus moto et scooter · 18 %</a:t>
             </a:r>
           </a:p>
         </p:txBody>
@@ -6493,7 +6493,7 @@
                 </a:solidFill>
                 <a:latin typeface="Arial"/>
               </a:rPr>
-              <a:t>Pneus moto et scooter · &lt; 1 %</a:t>
+              <a:t>Pneus toutes saisons · 1 %</a:t>
             </a:r>
           </a:p>
         </p:txBody>
@@ -6572,7 +6572,7 @@
                 </a:solidFill>
                 <a:latin typeface="Arial"/>
               </a:rPr>
-              <a:t>Pneus SUV et utilitaires · &lt; 1 %</a:t>
+              <a:t>Pneus hiver et neige · 1 %</a:t>
             </a:r>
           </a:p>
         </p:txBody>
@@ -6651,7 +6651,7 @@
                 </a:solidFill>
                 <a:latin typeface="Arial"/>
               </a:rPr>
-              <a:t>Pneus hiver et neige · 9 %</a:t>
+              <a:t>Accessoires et entretien · &lt; 1 %</a:t>
             </a:r>
           </a:p>
         </p:txBody>
@@ -6665,7 +6665,7 @@
         <p:spPr>
           <a:xfrm>
             <a:off x="10564368" y="4450080"/>
-            <a:ext cx="475488" cy="1086307"/>
+            <a:ext cx="475488" cy="549859"/>
           </a:xfrm>
           <a:prstGeom prst="rect">
             <a:avLst/>
@@ -6709,7 +6709,7 @@
         <p:spPr>
           <a:xfrm>
             <a:off x="10564368" y="4450080"/>
-            <a:ext cx="475488" cy="1086307"/>
+            <a:ext cx="475488" cy="549859"/>
           </a:xfrm>
           <a:prstGeom prst="rect">
             <a:avLst/>
@@ -6730,7 +6730,7 @@
                 </a:solidFill>
                 <a:latin typeface="Arial"/>
               </a:rPr>
-              <a:t>81 %</a:t>
+              <a:t>41 %</a:t>
             </a:r>
           </a:p>
         </p:txBody>
@@ -6743,8 +6743,8 @@
         </p:nvSpPr>
         <p:spPr>
           <a:xfrm>
-            <a:off x="10564368" y="5536387"/>
-            <a:ext cx="475488" cy="26822"/>
+            <a:off x="10564368" y="4999939"/>
+            <a:ext cx="475488" cy="523036"/>
           </a:xfrm>
           <a:prstGeom prst="rect">
             <a:avLst/>
@@ -6781,14 +6781,49 @@
       </p:sp>
       <p:sp>
         <p:nvSpPr>
-          <p:cNvPr id="95" name="Rectangle 94"/>
+          <p:cNvPr id="95" name="TextBox 94"/>
+          <p:cNvSpPr txBox="1"/>
+          <p:nvPr/>
+        </p:nvSpPr>
+        <p:spPr>
+          <a:xfrm>
+            <a:off x="10564368" y="4999939"/>
+            <a:ext cx="475488" cy="523036"/>
+          </a:xfrm>
+          <a:prstGeom prst="rect">
+            <a:avLst/>
+          </a:prstGeom>
+          <a:noFill/>
+        </p:spPr>
+        <p:txBody>
+          <a:bodyPr wrap="square" anchor="ctr" lIns="0" rIns="0" tIns="0" bIns="0">
+            <a:spAutoFit/>
+          </a:bodyPr>
+          <a:lstStyle/>
+          <a:p>
+            <a:pPr algn="ctr"/>
+            <a:r>
+              <a:rPr sz="1000" b="1" i="0">
+                <a:solidFill>
+                  <a:srgbClr val="FFFFFF"/>
+                </a:solidFill>
+                <a:latin typeface="Arial"/>
+              </a:rPr>
+              <a:t>39 %</a:t>
+            </a:r>
+          </a:p>
+        </p:txBody>
+      </p:sp>
+      <p:sp>
+        <p:nvSpPr>
+          <p:cNvPr id="96" name="Rectangle 95"/>
           <p:cNvSpPr/>
           <p:nvPr/>
         </p:nvSpPr>
         <p:spPr>
           <a:xfrm>
-            <a:off x="10564368" y="5563209"/>
-            <a:ext cx="475488" cy="107289"/>
+            <a:off x="10564368" y="5522976"/>
+            <a:ext cx="475488" cy="241401"/>
           </a:xfrm>
           <a:prstGeom prst="rect">
             <a:avLst/>
@@ -6825,14 +6860,14 @@
       </p:sp>
       <p:sp>
         <p:nvSpPr>
-          <p:cNvPr id="96" name="Rectangle 95"/>
+          <p:cNvPr id="97" name="Rectangle 96"/>
           <p:cNvSpPr/>
           <p:nvPr/>
         </p:nvSpPr>
         <p:spPr>
           <a:xfrm>
-            <a:off x="10564368" y="5670499"/>
-            <a:ext cx="475488" cy="0"/>
+            <a:off x="10564368" y="5764377"/>
+            <a:ext cx="475488" cy="13411"/>
           </a:xfrm>
           <a:prstGeom prst="rect">
             <a:avLst/>
@@ -6869,14 +6904,14 @@
       </p:sp>
       <p:sp>
         <p:nvSpPr>
-          <p:cNvPr id="97" name="Rectangle 96"/>
+          <p:cNvPr id="98" name="Rectangle 97"/>
           <p:cNvSpPr/>
           <p:nvPr/>
         </p:nvSpPr>
         <p:spPr>
           <a:xfrm>
-            <a:off x="10564368" y="5670499"/>
-            <a:ext cx="475488" cy="0"/>
+            <a:off x="10564368" y="5777788"/>
+            <a:ext cx="475488" cy="13411"/>
           </a:xfrm>
           <a:prstGeom prst="rect">
             <a:avLst/>
@@ -6913,14 +6948,14 @@
       </p:sp>
       <p:sp>
         <p:nvSpPr>
-          <p:cNvPr id="98" name="Rectangle 97"/>
+          <p:cNvPr id="99" name="Rectangle 98"/>
           <p:cNvSpPr/>
           <p:nvPr/>
         </p:nvSpPr>
         <p:spPr>
           <a:xfrm>
-            <a:off x="10564368" y="5670499"/>
-            <a:ext cx="475488" cy="120700"/>
+            <a:off x="10564368" y="5791200"/>
+            <a:ext cx="475488" cy="0"/>
           </a:xfrm>
           <a:prstGeom prst="rect">
             <a:avLst/>
@@ -7356,7 +7391,7 @@
                 </a:solidFill>
                 <a:latin typeface="Arial"/>
               </a:rPr>
-              <a:t>Présenter le 4 saisons comme la réponse à l'hiver</a:t>
+              <a:t>Les pneus hiver cliquent le plus</a:t>
             </a:r>
           </a:p>
         </p:txBody>
@@ -7391,7 +7426,7 @@
                 </a:solidFill>
                 <a:latin typeface="Arial"/>
               </a:rPr>
-              <a:t>Pneus hiver et chaînes à neige pèsent 8,5 % des produits nommés, avec des questions sur la loi montagne et le 3PMSF. Or 30 des 47 références du catalogue sont des pneus 4 saisons certifiés 3PMSF (Continental, Dunlop, Falken).</a:t>
+              <a:t>Les annonces de pneus hiver (Michelin Alpin 7, Hankook Winter i*cept, Ilink Winter) atteignent 1,15 fois le CTR moyen, devant les 4 saisons (1,02 fois). Elles ne représentent pourtant que 8 % des impressions.</a:t>
             </a:r>
           </a:p>
         </p:txBody>
@@ -7426,7 +7461,7 @@
                 </a:solidFill>
                 <a:latin typeface="Arial"/>
               </a:rPr>
-              <a:t>→  Accroche type : « Pneus 4 saisons 3PMSF : conformes à la loi montagne, sans changer de pneus à chaque saison ».</a:t>
+              <a:t>→  Augmenter la part des pneus hiver et 4 saisons 3PMSF dans la diffusion d'octobre, au moment des changements de pneus.</a:t>
             </a:r>
           </a:p>
         </p:txBody>
@@ -7542,7 +7577,7 @@
                 </a:solidFill>
                 <a:latin typeface="Arial"/>
               </a:rPr>
-              <a:t>Rassurer sur le rapport sécurité / prix</a:t>
+              <a:t>Renforcer les SUV, revoir les utilitaires</a:t>
             </a:r>
           </a:p>
         </p:txBody>
@@ -7577,7 +7612,7 @@
                 </a:solidFill>
                 <a:latin typeface="Arial"/>
               </a:rPr>
-              <a:t>Les requêtes associent prix et sécurité (« pas chers mais sûrs », distances de freinage à 130 km/h). Le catalogue va de 52 € à 249 € le pneu, avec des marques premium (Continental, Bridgestone, Dunlop).</a:t>
+              <a:t>Les pneus SUV et 4x4 atteignent 1,09 fois la moyenne (Kleber Quadraxer SUV : 1,43 fois). Les utilitaires tombent à 0,87 fois (VanContact 4Season : 0,40 fois).</a:t>
             </a:r>
           </a:p>
         </p:txBody>
@@ -7612,7 +7647,7 @@
                 </a:solidFill>
                 <a:latin typeface="Arial"/>
               </a:rPr>
-              <a:t>→  Mettre en avant les marques premium à prix accessible et les étiquettes européennes (freinage sur sol mouillé, bruit).</a:t>
+              <a:t>→  Pousser les références SUV et retravailler les messages utilitaires autour d'un usage concret (charge, chantier, camping-car).</a:t>
             </a:r>
           </a:p>
         </p:txBody>
@@ -7728,7 +7763,7 @@
                 </a:solidFill>
                 <a:latin typeface="Arial"/>
               </a:rPr>
-              <a:t>Répondre aux conducteurs de voitures électriques</a:t>
+              <a:t>Miser sur les marques au bon rapport qualité-prix</a:t>
             </a:r>
           </a:p>
         </p:txBody>
@@ -7763,7 +7798,7 @@
                 </a:solidFill>
                 <a:latin typeface="Arial"/>
               </a:rPr>
-              <a:t>Plusieurs requêtes citent un modèle électrique (MG4 EV, Zoé 2020) et cherchent des pneus adaptés ou certifiés 3PMSF.</a:t>
+              <a:t>Hankook (1,22 fois la moyenne) et Ilink (1,12 fois) surperforment, alors que Goodyear (0,69 fois) et Bridgestone (0,82 fois) restent sous la moyenne.</a:t>
             </a:r>
           </a:p>
         </p:txBody>
@@ -7798,7 +7833,7 @@
                 </a:solidFill>
                 <a:latin typeface="Arial"/>
               </a:rPr>
-              <a:t>→  Proposer les dimensions compatibles avec ces modèles et mettre en avant le silence de roulement et l'adhérence.</a:t>
+              <a:t>→  Mettre en avant les marques à prix accessible dans les accroches « pas cher mais sûr ».</a:t>
             </a:r>
           </a:p>
         </p:txBody>
@@ -7914,7 +7949,7 @@
                 </a:solidFill>
                 <a:latin typeface="Arial"/>
               </a:rPr>
-              <a:t>Une visibilité en forte hausse</a:t>
+              <a:t>Diversifier les descriptions</a:t>
             </a:r>
           </a:p>
         </p:txBody>
@@ -7949,7 +7984,7 @@
                 </a:solidFill>
                 <a:latin typeface="Arial"/>
               </a:rPr>
-              <a:t>Allo Pneus passe à 7,0 % de part de voix (+5,7 pts) et 21,3 % côté ads (+7,0 pts). Le CTR passe de 0,15 % à 0,40 % malgré l'arrêt de diffusion du 10 au 14/09.</a:t>
+              <a:t>70 des 84 annonces utilisent la même description (« Leader de la vente de pneus pas chers en ligne… ») et restent à 0,99 fois la moyenne. La même accroche moto varie de 0,53 à 1,32 fois selon l'emplacement.</a:t>
             </a:r>
           </a:p>
         </p:txBody>
@@ -7984,7 +8019,7 @@
                 </a:solidFill>
                 <a:latin typeface="Arial"/>
               </a:rPr>
-              <a:t>→  Maintenir la pression ads en octobre, au cœur de la saison du changement de pneus.</a:t>
+              <a:t>→  Tester des descriptions centrées sur un bénéfice précis (adhérence sous la pluie, loi montagne, montage à domicile).</a:t>
             </a:r>
           </a:p>
         </p:txBody>

</xml_diff>

<commit_message>
Allo Pneus : insights reformulés
Co-Authored-By: Claude Opus 5.5 <noreply@anthropic.com>
Claude-Session: https://claude.ai/code/session_01BmxtdWjbeRUyPx9e1qVLbT
</commit_message>
<xml_diff>
--- a/rapports/septembre/Allo_Pneus_sept2026.pptx
+++ b/rapports/septembre/Allo_Pneus_sept2026.pptx
@@ -7391,7 +7391,7 @@
                 </a:solidFill>
                 <a:latin typeface="Arial"/>
               </a:rPr>
-              <a:t>Les pneus hiver cliquent le plus</a:t>
+              <a:t>Mettre davantage en avant les pneus hiver</a:t>
             </a:r>
           </a:p>
         </p:txBody>
@@ -7426,7 +7426,7 @@
                 </a:solidFill>
                 <a:latin typeface="Arial"/>
               </a:rPr>
-              <a:t>Les annonces de pneus hiver (Michelin Alpin 7, Hankook Winter i*cept, Ilink Winter) atteignent 1,15 fois le CTR moyen, devant les 4 saisons (1,02 fois). Elles ne représentent pourtant que 8 % des impressions.</a:t>
+              <a:t>Les annonces de pneus hiver atteignent 1,15 fois le CTR moyen, le meilleur score du mois. Elles ne représentent pourtant que 8 % de la diffusion.</a:t>
             </a:r>
           </a:p>
         </p:txBody>
@@ -7461,7 +7461,7 @@
                 </a:solidFill>
                 <a:latin typeface="Arial"/>
               </a:rPr>
-              <a:t>→  Augmenter la part des pneus hiver et 4 saisons 3PMSF dans la diffusion d'octobre, au moment des changements de pneus.</a:t>
+              <a:t>→  Augmenter la part des pneus hiver et 4 saisons en octobre, au moment où les conducteurs changent leurs pneus.</a:t>
             </a:r>
           </a:p>
         </p:txBody>
@@ -7577,7 +7577,7 @@
                 </a:solidFill>
                 <a:latin typeface="Arial"/>
               </a:rPr>
-              <a:t>Renforcer les SUV, revoir les utilitaires</a:t>
+              <a:t>Renforcer les pneus SUV</a:t>
             </a:r>
           </a:p>
         </p:txBody>
@@ -7612,7 +7612,7 @@
                 </a:solidFill>
                 <a:latin typeface="Arial"/>
               </a:rPr>
-              <a:t>Les pneus SUV et 4x4 atteignent 1,09 fois la moyenne (Kleber Quadraxer SUV : 1,43 fois). Les utilitaires tombent à 0,87 fois (VanContact 4Season : 0,40 fois).</a:t>
+              <a:t>Les pneus SUV et 4x4 atteignent 1,09 fois le CTR moyen, et jusqu'à 1,43 fois pour le Kleber Quadraxer SUV. Les pneus utilitaires restent sous la moyenne (0,87 fois).</a:t>
             </a:r>
           </a:p>
         </p:txBody>
@@ -7647,7 +7647,7 @@
                 </a:solidFill>
                 <a:latin typeface="Arial"/>
               </a:rPr>
-              <a:t>→  Pousser les références SUV et retravailler les messages utilitaires autour d'un usage concret (charge, chantier, camping-car).</a:t>
+              <a:t>→  Donner plus de visibilité aux références SUV et retravailler les messages utilitaires autour d'un usage concret (chantier, camping-car).</a:t>
             </a:r>
           </a:p>
         </p:txBody>
@@ -7763,7 +7763,7 @@
                 </a:solidFill>
                 <a:latin typeface="Arial"/>
               </a:rPr>
-              <a:t>Miser sur les marques au bon rapport qualité-prix</a:t>
+              <a:t>Privilégier les marques au bon rapport qualité-prix</a:t>
             </a:r>
           </a:p>
         </p:txBody>
@@ -7798,7 +7798,7 @@
                 </a:solidFill>
                 <a:latin typeface="Arial"/>
               </a:rPr>
-              <a:t>Hankook (1,22 fois la moyenne) et Ilink (1,12 fois) surperforment, alors que Goodyear (0,69 fois) et Bridgestone (0,82 fois) restent sous la moyenne.</a:t>
+              <a:t>Les marques à prix accessible cliquent mieux : Hankook atteint 1,22 fois le CTR moyen. Les marques premium comme Goodyear restent en dessous (0,69 fois).</a:t>
             </a:r>
           </a:p>
         </p:txBody>
@@ -7833,7 +7833,7 @@
                 </a:solidFill>
                 <a:latin typeface="Arial"/>
               </a:rPr>
-              <a:t>→  Mettre en avant les marques à prix accessible dans les accroches « pas cher mais sûr ».</a:t>
+              <a:t>→  Mettre en avant les marques accessibles avec le message « pas cher mais sûr ».</a:t>
             </a:r>
           </a:p>
         </p:txBody>
@@ -7949,7 +7949,7 @@
                 </a:solidFill>
                 <a:latin typeface="Arial"/>
               </a:rPr>
-              <a:t>Diversifier les descriptions</a:t>
+              <a:t>Varier les descriptions des annonces</a:t>
             </a:r>
           </a:p>
         </p:txBody>
@@ -7984,7 +7984,7 @@
                 </a:solidFill>
                 <a:latin typeface="Arial"/>
               </a:rPr>
-              <a:t>70 des 84 annonces utilisent la même description (« Leader de la vente de pneus pas chers en ligne… ») et restent à 0,99 fois la moyenne. La même accroche moto varie de 0,53 à 1,32 fois selon l'emplacement.</a:t>
+              <a:t>La plupart des annonces utilisent la même description (« Leader de la vente de pneus pas chers en ligne ») et restent dans la moyenne.</a:t>
             </a:r>
           </a:p>
         </p:txBody>
@@ -8019,7 +8019,7 @@
                 </a:solidFill>
                 <a:latin typeface="Arial"/>
               </a:rPr>
-              <a:t>→  Tester des descriptions centrées sur un bénéfice précis (adhérence sous la pluie, loi montagne, montage à domicile).</a:t>
+              <a:t>→  Tester des descriptions avec un bénéfice précis : adhérence sous la pluie, conformité loi montagne, montage à domicile.</a:t>
             </a:r>
           </a:p>
         </p:txBody>

</xml_diff>